<commit_message>
task133 loop 1: rebuilt pack, goldens and target.zip
Fifteen input files (five new: the June quarter-end extract, the scoring
runs, the 2023-24 defaults, the receipts ledger, the debt-sale schedule);
distractors are now the roll-rate workbook and the write-off file. Golden
allowance AUD 13,160,000 (stage 1 10,563,000, stage 2 2,597,000); the
workbook carries the realised-loss grid and the migration counts, the
deck's second slide the stacked migration chart. Two scratch rebuilds are
byte-identical to target/, golden/ and target.zip.

Co-Authored-By: Claude Opus 5.5 <noreply@anthropic.com>
Claude-Session: https://claude.ai/code/session_01A6XcFx5t62c7gPi1bBKcVi
</commit_message>
<xml_diff>
--- a/task133/golden/board_ecl_q3_2026.pptx
+++ b/task133/golden/board_ecl_q3_2026.pptx
@@ -115,8 +115,8 @@
     <c:autoTitleDeleted val="0"/>
     <c:plotArea>
       <c:barChart>
-        <c:barDir val="col"/>
-        <c:grouping val="clustered"/>
+        <c:barDir val="bar"/>
+        <c:grouping val="percentStacked"/>
         <c:ser>
           <c:idx val="0"/>
           <c:order val="0"/>
@@ -126,17 +126,47 @@
               <c:strCache>
                 <c:ptCount val="1"/>
                 <c:pt idx="0">
-                  <c:v>PL36</c:v>
+                  <c:v>Stage 1 at 30 September</c:v>
                 </c:pt>
               </c:strCache>
             </c:strRef>
           </c:tx>
           <c:spPr>
             <a:solidFill>
-              <a:srgbClr val="2E6F73"/>
+              <a:srgbClr val="2A78D6"/>
             </a:solidFill>
+            <a:ln w="19050">
+              <a:solidFill>
+                <a:srgbClr val="FFFFFF"/>
+              </a:solidFill>
+            </a:ln>
           </c:spPr>
           <c:dLbls>
+            <c:dLbl>
+              <c:idx val="0"/>
+              <c:tx>
+                <c:rich>
+                  <a:bodyPr/>
+                  <a:lstStyle/>
+                  <a:p>
+                    <a:r>
+                      <a:rPr sz="1100" b="1">
+                        <a:solidFill>
+                          <a:srgbClr val="FFFFFF"/>
+                        </a:solidFill>
+                      </a:rPr>
+                      <a:t>14,470</a:t>
+                    </a:r>
+                  </a:p>
+                </c:rich>
+              </c:tx>
+              <c:showLegendKey val="0"/>
+              <c:showVal val="1"/>
+              <c:showCatName val="0"/>
+              <c:showSerName val="0"/>
+              <c:showPercent val="0"/>
+              <c:showBubbleSize val="0"/>
+            </c:dLbl>
             <c:dLbl>
               <c:idx val="1"/>
               <c:tx>
@@ -145,12 +175,12 @@
                   <a:lstStyle/>
                   <a:p>
                     <a:r>
-                      <a:rPr sz="1000">
+                      <a:rPr sz="1100" b="1">
                         <a:solidFill>
-                          <a:srgbClr val="1E2B3C"/>
+                          <a:srgbClr val="FFFFFF"/>
                         </a:solidFill>
                       </a:rPr>
-                      <a:t>$0.2m</a:t>
+                      <a:t>468</a:t>
                     </a:r>
                   </a:p>
                 </c:rich>
@@ -170,12 +200,12 @@
                   <a:lstStyle/>
                   <a:p>
                     <a:r>
-                      <a:rPr sz="1000">
+                      <a:rPr sz="1100" b="1">
                         <a:solidFill>
-                          <a:srgbClr val="1E2B3C"/>
+                          <a:srgbClr val="FFFFFF"/>
                         </a:solidFill>
                       </a:rPr>
-                      <a:t>$0.9m</a:t>
+                      <a:t>17,724</a:t>
                     </a:r>
                   </a:p>
                 </c:rich>
@@ -195,12 +225,12 @@
                   <a:lstStyle/>
                   <a:p>
                     <a:r>
-                      <a:rPr sz="1000">
+                      <a:rPr sz="1100" b="1">
                         <a:solidFill>
-                          <a:srgbClr val="1E2B3C"/>
+                          <a:srgbClr val="FFFFFF"/>
                         </a:solidFill>
                       </a:rPr>
-                      <a:t>$2.8m</a:t>
+                      <a:t>560</a:t>
                     </a:r>
                   </a:p>
                 </c:rich>
@@ -226,16 +256,16 @@
               <c:strCache>
                 <c:ptCount val="4"/>
                 <c:pt idx="0">
-                  <c:v>2023 and earlier</c:v>
+                  <c:v>PL36, stage 1 at 30 June</c:v>
                 </c:pt>
                 <c:pt idx="1">
-                  <c:v>2024</c:v>
+                  <c:v>PL36, stage 2 at 30 June</c:v>
                 </c:pt>
                 <c:pt idx="2">
-                  <c:v>2025</c:v>
+                  <c:v>PL60, stage 1 at 30 June</c:v>
                 </c:pt>
                 <c:pt idx="3">
-                  <c:v>2026</c:v>
+                  <c:v>PL60, stage 2 at 30 June</c:v>
                 </c:pt>
               </c:strCache>
             </c:strRef>
@@ -247,16 +277,16 @@
                 <c:formatCode>General</c:formatCode>
                 <c:ptCount val="4"/>
                 <c:pt idx="0">
-                  <c:v>0.005</c:v>
+                  <c:v>14470</c:v>
                 </c:pt>
                 <c:pt idx="1">
-                  <c:v>0.159</c:v>
+                  <c:v>468</c:v>
                 </c:pt>
                 <c:pt idx="2">
-                  <c:v>0.94</c:v>
+                  <c:v>17724</c:v>
                 </c:pt>
                 <c:pt idx="3">
-                  <c:v>2.779</c:v>
+                  <c:v>560</c:v>
                 </c:pt>
               </c:numCache>
             </c:numRef>
@@ -271,15 +301,20 @@
               <c:strCache>
                 <c:ptCount val="1"/>
                 <c:pt idx="0">
-                  <c:v>PL60</c:v>
+                  <c:v>Stage 2</c:v>
                 </c:pt>
               </c:strCache>
             </c:strRef>
           </c:tx>
           <c:spPr>
             <a:solidFill>
-              <a:srgbClr val="C9A25F"/>
+              <a:srgbClr val="EDA100"/>
             </a:solidFill>
+            <a:ln w="19050">
+              <a:solidFill>
+                <a:srgbClr val="FFFFFF"/>
+              </a:solidFill>
+            </a:ln>
           </c:spPr>
           <c:dLbls>
             <c:dLbl>
@@ -290,12 +325,12 @@
                   <a:lstStyle/>
                   <a:p>
                     <a:r>
-                      <a:rPr sz="1000">
+                      <a:rPr sz="1100" b="1">
                         <a:solidFill>
                           <a:srgbClr val="1E2B3C"/>
                         </a:solidFill>
                       </a:rPr>
-                      <a:t>$0.6m</a:t>
+                      <a:t>680</a:t>
                     </a:r>
                   </a:p>
                 </c:rich>
@@ -315,12 +350,12 @@
                   <a:lstStyle/>
                   <a:p>
                     <a:r>
-                      <a:rPr sz="1000">
+                      <a:rPr sz="1100" b="1">
                         <a:solidFill>
                           <a:srgbClr val="1E2B3C"/>
                         </a:solidFill>
                       </a:rPr>
-                      <a:t>$1.1m</a:t>
+                      <a:t>658</a:t>
                     </a:r>
                   </a:p>
                 </c:rich>
@@ -340,12 +375,12 @@
                   <a:lstStyle/>
                   <a:p>
                     <a:r>
-                      <a:rPr sz="1000">
+                      <a:rPr sz="1100" b="1">
                         <a:solidFill>
                           <a:srgbClr val="1E2B3C"/>
                         </a:solidFill>
                       </a:rPr>
-                      <a:t>$2.4m</a:t>
+                      <a:t>831</a:t>
                     </a:r>
                   </a:p>
                 </c:rich>
@@ -365,12 +400,12 @@
                   <a:lstStyle/>
                   <a:p>
                     <a:r>
-                      <a:rPr sz="1000">
+                      <a:rPr sz="1100" b="1">
                         <a:solidFill>
                           <a:srgbClr val="1E2B3C"/>
                         </a:solidFill>
                       </a:rPr>
-                      <a:t>$5.8m</a:t>
+                      <a:t>942</a:t>
                     </a:r>
                   </a:p>
                 </c:rich>
@@ -396,16 +431,16 @@
               <c:strCache>
                 <c:ptCount val="4"/>
                 <c:pt idx="0">
-                  <c:v>2023 and earlier</c:v>
+                  <c:v>PL36, stage 1 at 30 June</c:v>
                 </c:pt>
                 <c:pt idx="1">
-                  <c:v>2024</c:v>
+                  <c:v>PL36, stage 2 at 30 June</c:v>
                 </c:pt>
                 <c:pt idx="2">
-                  <c:v>2025</c:v>
+                  <c:v>PL60, stage 1 at 30 June</c:v>
                 </c:pt>
                 <c:pt idx="3">
-                  <c:v>2026</c:v>
+                  <c:v>PL60, stage 2 at 30 June</c:v>
                 </c:pt>
               </c:strCache>
             </c:strRef>
@@ -417,31 +452,397 @@
                 <c:formatCode>General</c:formatCode>
                 <c:ptCount val="4"/>
                 <c:pt idx="0">
-                  <c:v>0.641</c:v>
+                  <c:v>680</c:v>
                 </c:pt>
                 <c:pt idx="1">
-                  <c:v>1.073</c:v>
+                  <c:v>658</c:v>
                 </c:pt>
                 <c:pt idx="2">
-                  <c:v>2.412</c:v>
+                  <c:v>831</c:v>
                 </c:pt>
                 <c:pt idx="3">
-                  <c:v>5.763</c:v>
+                  <c:v>942</c:v>
                 </c:pt>
               </c:numCache>
             </c:numRef>
           </c:val>
         </c:ser>
+        <c:ser>
+          <c:idx val="2"/>
+          <c:order val="2"/>
+          <c:tx>
+            <c:strRef>
+              <c:f>Sheet1!$D$1</c:f>
+              <c:strCache>
+                <c:ptCount val="1"/>
+                <c:pt idx="0">
+                  <c:v>Stage 3</c:v>
+                </c:pt>
+              </c:strCache>
+            </c:strRef>
+          </c:tx>
+          <c:spPr>
+            <a:solidFill>
+              <a:srgbClr val="E34948"/>
+            </a:solidFill>
+            <a:ln w="19050">
+              <a:solidFill>
+                <a:srgbClr val="FFFFFF"/>
+              </a:solidFill>
+            </a:ln>
+          </c:spPr>
+          <c:dLbls>
+            <c:dLbl>
+              <c:idx val="0"/>
+              <c:layout>
+                <c:manualLayout>
+                  <c:x val="0.0000"/>
+                  <c:y val="0.0850"/>
+                </c:manualLayout>
+              </c:layout>
+              <c:tx>
+                <c:rich>
+                  <a:bodyPr/>
+                  <a:lstStyle/>
+                  <a:p>
+                    <a:r>
+                      <a:rPr sz="1100" b="1">
+                        <a:solidFill>
+                          <a:srgbClr val="1E2B3C"/>
+                        </a:solidFill>
+                      </a:rPr>
+                      <a:t>42</a:t>
+                    </a:r>
+                  </a:p>
+                </c:rich>
+              </c:tx>
+              <c:dLblPos val="ctr"/>
+              <c:showLegendKey val="0"/>
+              <c:showVal val="1"/>
+              <c:showCatName val="0"/>
+              <c:showSerName val="0"/>
+              <c:showPercent val="0"/>
+              <c:showBubbleSize val="0"/>
+            </c:dLbl>
+            <c:dLbl>
+              <c:idx val="1"/>
+              <c:tx>
+                <c:rich>
+                  <a:bodyPr/>
+                  <a:lstStyle/>
+                  <a:p>
+                    <a:r>
+                      <a:rPr sz="1100" b="1">
+                        <a:solidFill>
+                          <a:srgbClr val="FFFFFF"/>
+                        </a:solidFill>
+                      </a:rPr>
+                      <a:t>115</a:t>
+                    </a:r>
+                  </a:p>
+                </c:rich>
+              </c:tx>
+              <c:showLegendKey val="0"/>
+              <c:showVal val="1"/>
+              <c:showCatName val="0"/>
+              <c:showSerName val="0"/>
+              <c:showPercent val="0"/>
+              <c:showBubbleSize val="0"/>
+            </c:dLbl>
+            <c:dLbl>
+              <c:idx val="2"/>
+              <c:layout>
+                <c:manualLayout>
+                  <c:x val="0.0000"/>
+                  <c:y val="0.0850"/>
+                </c:manualLayout>
+              </c:layout>
+              <c:tx>
+                <c:rich>
+                  <a:bodyPr/>
+                  <a:lstStyle/>
+                  <a:p>
+                    <a:r>
+                      <a:rPr sz="1100" b="1">
+                        <a:solidFill>
+                          <a:srgbClr val="1E2B3C"/>
+                        </a:solidFill>
+                      </a:rPr>
+                      <a:t>46</a:t>
+                    </a:r>
+                  </a:p>
+                </c:rich>
+              </c:tx>
+              <c:dLblPos val="ctr"/>
+              <c:showLegendKey val="0"/>
+              <c:showVal val="1"/>
+              <c:showCatName val="0"/>
+              <c:showSerName val="0"/>
+              <c:showPercent val="0"/>
+              <c:showBubbleSize val="0"/>
+            </c:dLbl>
+            <c:dLbl>
+              <c:idx val="3"/>
+              <c:tx>
+                <c:rich>
+                  <a:bodyPr/>
+                  <a:lstStyle/>
+                  <a:p>
+                    <a:r>
+                      <a:rPr sz="1100" b="1">
+                        <a:solidFill>
+                          <a:srgbClr val="FFFFFF"/>
+                        </a:solidFill>
+                      </a:rPr>
+                      <a:t>140</a:t>
+                    </a:r>
+                  </a:p>
+                </c:rich>
+              </c:tx>
+              <c:showLegendKey val="0"/>
+              <c:showVal val="1"/>
+              <c:showCatName val="0"/>
+              <c:showSerName val="0"/>
+              <c:showPercent val="0"/>
+              <c:showBubbleSize val="0"/>
+            </c:dLbl>
+            <c:showLegendKey val="0"/>
+            <c:showVal val="0"/>
+            <c:showCatName val="0"/>
+            <c:showSerName val="0"/>
+            <c:showPercent val="0"/>
+            <c:showBubbleSize val="0"/>
+            <c:showLeaderLines val="1"/>
+          </c:dLbls>
+          <c:cat>
+            <c:strRef>
+              <c:f>Sheet1!$A$2:$A$5</c:f>
+              <c:strCache>
+                <c:ptCount val="4"/>
+                <c:pt idx="0">
+                  <c:v>PL36, stage 1 at 30 June</c:v>
+                </c:pt>
+                <c:pt idx="1">
+                  <c:v>PL36, stage 2 at 30 June</c:v>
+                </c:pt>
+                <c:pt idx="2">
+                  <c:v>PL60, stage 1 at 30 June</c:v>
+                </c:pt>
+                <c:pt idx="3">
+                  <c:v>PL60, stage 2 at 30 June</c:v>
+                </c:pt>
+              </c:strCache>
+            </c:strRef>
+          </c:cat>
+          <c:val>
+            <c:numRef>
+              <c:f>Sheet1!$D$2:$D$5</c:f>
+              <c:numCache>
+                <c:formatCode>General</c:formatCode>
+                <c:ptCount val="4"/>
+                <c:pt idx="0">
+                  <c:v>42</c:v>
+                </c:pt>
+                <c:pt idx="1">
+                  <c:v>115</c:v>
+                </c:pt>
+                <c:pt idx="2">
+                  <c:v>46</c:v>
+                </c:pt>
+                <c:pt idx="3">
+                  <c:v>140</c:v>
+                </c:pt>
+              </c:numCache>
+            </c:numRef>
+          </c:val>
+        </c:ser>
+        <c:ser>
+          <c:idx val="3"/>
+          <c:order val="3"/>
+          <c:tx>
+            <c:strRef>
+              <c:f>Sheet1!$E$1</c:f>
+              <c:strCache>
+                <c:ptCount val="1"/>
+                <c:pt idx="0">
+                  <c:v>Closed</c:v>
+                </c:pt>
+              </c:strCache>
+            </c:strRef>
+          </c:tx>
+          <c:spPr>
+            <a:solidFill>
+              <a:srgbClr val="6250D6"/>
+            </a:solidFill>
+            <a:ln w="19050">
+              <a:solidFill>
+                <a:srgbClr val="FFFFFF"/>
+              </a:solidFill>
+            </a:ln>
+          </c:spPr>
+          <c:dLbls>
+            <c:dLbl>
+              <c:idx val="0"/>
+              <c:tx>
+                <c:rich>
+                  <a:bodyPr/>
+                  <a:lstStyle/>
+                  <a:p>
+                    <a:r>
+                      <a:rPr sz="1100" b="1">
+                        <a:solidFill>
+                          <a:srgbClr val="FFFFFF"/>
+                        </a:solidFill>
+                      </a:rPr>
+                      <a:t>1,586</a:t>
+                    </a:r>
+                  </a:p>
+                </c:rich>
+              </c:tx>
+              <c:showLegendKey val="0"/>
+              <c:showVal val="1"/>
+              <c:showCatName val="0"/>
+              <c:showSerName val="0"/>
+              <c:showPercent val="0"/>
+              <c:showBubbleSize val="0"/>
+            </c:dLbl>
+            <c:dLbl>
+              <c:idx val="1"/>
+              <c:tx>
+                <c:rich>
+                  <a:bodyPr/>
+                  <a:lstStyle/>
+                  <a:p>
+                    <a:r>
+                      <a:rPr sz="1100" b="1">
+                        <a:solidFill>
+                          <a:srgbClr val="FFFFFF"/>
+                        </a:solidFill>
+                      </a:rPr>
+                      <a:t>123</a:t>
+                    </a:r>
+                  </a:p>
+                </c:rich>
+              </c:tx>
+              <c:showLegendKey val="0"/>
+              <c:showVal val="1"/>
+              <c:showCatName val="0"/>
+              <c:showSerName val="0"/>
+              <c:showPercent val="0"/>
+              <c:showBubbleSize val="0"/>
+            </c:dLbl>
+            <c:dLbl>
+              <c:idx val="2"/>
+              <c:tx>
+                <c:rich>
+                  <a:bodyPr/>
+                  <a:lstStyle/>
+                  <a:p>
+                    <a:r>
+                      <a:rPr sz="1100" b="1">
+                        <a:solidFill>
+                          <a:srgbClr val="FFFFFF"/>
+                        </a:solidFill>
+                      </a:rPr>
+                      <a:t>1,180</a:t>
+                    </a:r>
+                  </a:p>
+                </c:rich>
+              </c:tx>
+              <c:showLegendKey val="0"/>
+              <c:showVal val="1"/>
+              <c:showCatName val="0"/>
+              <c:showSerName val="0"/>
+              <c:showPercent val="0"/>
+              <c:showBubbleSize val="0"/>
+            </c:dLbl>
+            <c:dLbl>
+              <c:idx val="3"/>
+              <c:tx>
+                <c:rich>
+                  <a:bodyPr/>
+                  <a:lstStyle/>
+                  <a:p>
+                    <a:r>
+                      <a:rPr sz="1100" b="1">
+                        <a:solidFill>
+                          <a:srgbClr val="FFFFFF"/>
+                        </a:solidFill>
+                      </a:rPr>
+                      <a:t>112</a:t>
+                    </a:r>
+                  </a:p>
+                </c:rich>
+              </c:tx>
+              <c:showLegendKey val="0"/>
+              <c:showVal val="1"/>
+              <c:showCatName val="0"/>
+              <c:showSerName val="0"/>
+              <c:showPercent val="0"/>
+              <c:showBubbleSize val="0"/>
+            </c:dLbl>
+            <c:showLegendKey val="0"/>
+            <c:showVal val="0"/>
+            <c:showCatName val="0"/>
+            <c:showSerName val="0"/>
+            <c:showPercent val="0"/>
+            <c:showBubbleSize val="0"/>
+            <c:showLeaderLines val="1"/>
+          </c:dLbls>
+          <c:cat>
+            <c:strRef>
+              <c:f>Sheet1!$A$2:$A$5</c:f>
+              <c:strCache>
+                <c:ptCount val="4"/>
+                <c:pt idx="0">
+                  <c:v>PL36, stage 1 at 30 June</c:v>
+                </c:pt>
+                <c:pt idx="1">
+                  <c:v>PL36, stage 2 at 30 June</c:v>
+                </c:pt>
+                <c:pt idx="2">
+                  <c:v>PL60, stage 1 at 30 June</c:v>
+                </c:pt>
+                <c:pt idx="3">
+                  <c:v>PL60, stage 2 at 30 June</c:v>
+                </c:pt>
+              </c:strCache>
+            </c:strRef>
+          </c:cat>
+          <c:val>
+            <c:numRef>
+              <c:f>Sheet1!$E$2:$E$5</c:f>
+              <c:numCache>
+                <c:formatCode>General</c:formatCode>
+                <c:ptCount val="4"/>
+                <c:pt idx="0">
+                  <c:v>1586</c:v>
+                </c:pt>
+                <c:pt idx="1">
+                  <c:v>123</c:v>
+                </c:pt>
+                <c:pt idx="2">
+                  <c:v>1180</c:v>
+                </c:pt>
+                <c:pt idx="3">
+                  <c:v>112</c:v>
+                </c:pt>
+              </c:numCache>
+            </c:numRef>
+          </c:val>
+        </c:ser>
+        <c:gapWidth val="55"/>
+        <c:overlap val="100"/>
         <c:axId val="-2068027336"/>
         <c:axId val="-2113994440"/>
       </c:barChart>
       <c:catAx>
         <c:axId val="-2068027336"/>
         <c:scaling>
-          <c:orientation val="minMax"/>
+          <c:orientation val="maxMin"/>
         </c:scaling>
         <c:delete val="0"/>
-        <c:axPos val="b"/>
+        <c:axPos val="l"/>
         <c:majorTickMark val="out"/>
         <c:minorTickMark val="none"/>
         <c:tickLblPos val="nextTo"/>
@@ -450,7 +851,7 @@
           <a:lstStyle/>
           <a:p>
             <a:pPr>
-              <a:defRPr sz="1200"/>
+              <a:defRPr sz="1100"/>
             </a:pPr>
           </a:p>
         </c:txPr>
@@ -465,9 +866,8 @@
         <c:axId val="-2113994440"/>
         <c:scaling/>
         <c:delete val="0"/>
-        <c:axPos val="l"/>
-        <c:majorGridlines/>
-        <c:numFmt formatCode="&quot;$&quot;0.0&quot;m&quot;" sourceLinked="0"/>
+        <c:axPos val="b"/>
+        <c:numFmt formatCode="0%" sourceLinked="0"/>
         <c:majorTickMark val="out"/>
         <c:minorTickMark val="none"/>
         <c:tickLblPos val="nextTo"/>
@@ -476,7 +876,7 @@
           <a:lstStyle/>
           <a:p>
             <a:pPr>
-              <a:defRPr sz="1100"/>
+              <a:defRPr sz="1000"/>
             </a:pPr>
           </a:p>
         </c:txPr>
@@ -487,6 +887,15 @@
     <c:legend>
       <c:legendPos val="t"/>
       <c:overlay val="0"/>
+      <c:txPr>
+        <a:bodyPr/>
+        <a:lstStyle/>
+        <a:p>
+          <a:pPr>
+            <a:defRPr sz="1100"/>
+          </a:pPr>
+        </a:p>
+      </c:txPr>
     </c:legend>
     <c:dispBlanksAs val="gap"/>
   </c:chart>
@@ -3515,7 +3924,7 @@
                   <a:srgbClr val="1E2B3C"/>
                 </a:solidFill>
               </a:rPr>
-              <a:t>Book a collective ECL allowance of $13,773,000 on personal loans at 30 September 2026</a:t>
+              <a:t>Book a collective ECL allowance of $13,160,000 at 30 September 2026</a:t>
             </a:r>
           </a:p>
           <a:p>
@@ -3525,7 +3934,7 @@
                   <a:srgbClr val="5B6670"/>
                 </a:solidFill>
               </a:rPr>
-              <a:t>Stage 1 $10,933,000, stage 2 $2,840,000; 343 loans in stage 3 sit outside the collective model</a:t>
+              <a:t>Stage 1 $10,563,000 and stage 2 $2,597,000; 343 loans in stage 3 are assessed separately under CRM-ECL-06</a:t>
             </a:r>
           </a:p>
         </p:txBody>
@@ -3539,8 +3948,8 @@
           <p:nvPr/>
         </p:nvGraphicFramePr>
         <p:xfrm>
-          <a:off x="576000" y="1872000"/>
-          <a:ext cx="10980000" cy="2520000"/>
+          <a:off x="576000" y="1944000"/>
+          <a:ext cx="6839999" cy="1872000"/>
         </p:xfrm>
         <a:graphic>
           <a:graphicData uri="http://schemas.openxmlformats.org/drawingml/2006/table">
@@ -3549,47 +3958,23 @@
                 <a:tableStyleId>{5C22544A-7EE6-4342-B048-85BDC9FD1C3A}</a:tableStyleId>
               </a:tblPr>
               <a:tblGrid>
-                <a:gridCol w="1296000"/>
-                <a:gridCol w="1296000"/>
-                <a:gridCol w="1512000"/>
-                <a:gridCol w="2664000"/>
-                <a:gridCol w="2304000"/>
-                <a:gridCol w="1908000"/>
+                <a:gridCol w="3096000"/>
+                <a:gridCol w="1655999"/>
+                <a:gridCol w="2088000"/>
               </a:tblGrid>
-              <a:tr h="504000">
+              <a:tr h="468000">
                 <a:tc>
                   <a:txBody>
                     <a:bodyPr/>
                     <a:lstStyle/>
                     <a:p>
                       <a:r>
-                        <a:rPr sz="1400" b="1">
+                        <a:rPr sz="1600" b="1">
                           <a:solidFill>
                             <a:srgbClr val="FFFFFF"/>
                           </a:solidFill>
                         </a:rPr>
-                        <a:t>Stage</a:t>
-                      </a:r>
-                    </a:p>
-                  </a:txBody>
-                  <a:tcPr>
-                    <a:solidFill>
-                      <a:srgbClr val="1E2B3C"/>
-                    </a:solidFill>
-                  </a:tcPr>
-                </a:tc>
-                <a:tc>
-                  <a:txBody>
-                    <a:bodyPr/>
-                    <a:lstStyle/>
-                    <a:p>
-                      <a:r>
-                        <a:rPr sz="1400" b="1">
-                          <a:solidFill>
-                            <a:srgbClr val="FFFFFF"/>
-                          </a:solidFill>
-                        </a:rPr>
-                        <a:t>Product</a:t>
+                        <a:t/>
                       </a:r>
                     </a:p>
                   </a:txBody>
@@ -3606,7 +3991,7 @@
                     <a:p>
                       <a:pPr algn="r"/>
                       <a:r>
-                        <a:rPr sz="1400" b="1">
+                        <a:rPr sz="1600" b="1">
                           <a:solidFill>
                             <a:srgbClr val="FFFFFF"/>
                           </a:solidFill>
@@ -3628,29 +4013,7 @@
                     <a:p>
                       <a:pPr algn="r"/>
                       <a:r>
-                        <a:rPr sz="1400" b="1">
-                          <a:solidFill>
-                            <a:srgbClr val="FFFFFF"/>
-                          </a:solidFill>
-                        </a:rPr>
-                        <a:t>Gross carrying amount</a:t>
-                      </a:r>
-                    </a:p>
-                  </a:txBody>
-                  <a:tcPr>
-                    <a:solidFill>
-                      <a:srgbClr val="1E2B3C"/>
-                    </a:solidFill>
-                  </a:tcPr>
-                </a:tc>
-                <a:tc>
-                  <a:txBody>
-                    <a:bodyPr/>
-                    <a:lstStyle/>
-                    <a:p>
-                      <a:pPr algn="r"/>
-                      <a:r>
-                        <a:rPr sz="1400" b="1">
+                        <a:rPr sz="1600" b="1">
                           <a:solidFill>
                             <a:srgbClr val="FFFFFF"/>
                           </a:solidFill>
@@ -3665,37 +4028,15 @@
                     </a:solidFill>
                   </a:tcPr>
                 </a:tc>
-                <a:tc>
-                  <a:txBody>
-                    <a:bodyPr/>
-                    <a:lstStyle/>
-                    <a:p>
-                      <a:pPr algn="r"/>
-                      <a:r>
-                        <a:rPr sz="1400" b="1">
-                          <a:solidFill>
-                            <a:srgbClr val="FFFFFF"/>
-                          </a:solidFill>
-                        </a:rPr>
-                        <a:t>Coverage</a:t>
-                      </a:r>
-                    </a:p>
-                  </a:txBody>
-                  <a:tcPr>
-                    <a:solidFill>
-                      <a:srgbClr val="1E2B3C"/>
-                    </a:solidFill>
-                  </a:tcPr>
-                </a:tc>
               </a:tr>
-              <a:tr h="504000">
+              <a:tr h="468000">
                 <a:tc>
                   <a:txBody>
                     <a:bodyPr/>
                     <a:lstStyle/>
                     <a:p>
                       <a:r>
-                        <a:rPr sz="1400" b="0">
+                        <a:rPr sz="1600" b="0">
                           <a:solidFill>
                             <a:srgbClr val="1E2B3C"/>
                           </a:solidFill>
@@ -3715,13 +4056,14 @@
                     <a:bodyPr/>
                     <a:lstStyle/>
                     <a:p>
+                      <a:pPr algn="r"/>
                       <a:r>
-                        <a:rPr sz="1400" b="0">
+                        <a:rPr sz="1600" b="0">
                           <a:solidFill>
                             <a:srgbClr val="1E2B3C"/>
                           </a:solidFill>
                         </a:rPr>
-                        <a:t>PL36</a:t>
+                        <a:t>37,288</a:t>
                       </a:r>
                     </a:p>
                   </a:txBody>
@@ -3738,78 +4080,12 @@
                     <a:p>
                       <a:pPr algn="r"/>
                       <a:r>
-                        <a:rPr sz="1400" b="0">
+                        <a:rPr sz="1600" b="0">
                           <a:solidFill>
                             <a:srgbClr val="1E2B3C"/>
                           </a:solidFill>
                         </a:rPr>
-                        <a:t>17,109</a:t>
-                      </a:r>
-                    </a:p>
-                  </a:txBody>
-                  <a:tcPr>
-                    <a:solidFill>
-                      <a:srgbClr val="FFFFFF"/>
-                    </a:solidFill>
-                  </a:tcPr>
-                </a:tc>
-                <a:tc>
-                  <a:txBody>
-                    <a:bodyPr/>
-                    <a:lstStyle/>
-                    <a:p>
-                      <a:pPr algn="r"/>
-                      <a:r>
-                        <a:rPr sz="1400" b="0">
-                          <a:solidFill>
-                            <a:srgbClr val="1E2B3C"/>
-                          </a:solidFill>
-                        </a:rPr>
-                        <a:t>$138,349,000</a:t>
-                      </a:r>
-                    </a:p>
-                  </a:txBody>
-                  <a:tcPr>
-                    <a:solidFill>
-                      <a:srgbClr val="FFFFFF"/>
-                    </a:solidFill>
-                  </a:tcPr>
-                </a:tc>
-                <a:tc>
-                  <a:txBody>
-                    <a:bodyPr/>
-                    <a:lstStyle/>
-                    <a:p>
-                      <a:pPr algn="r"/>
-                      <a:r>
-                        <a:rPr sz="1400" b="0">
-                          <a:solidFill>
-                            <a:srgbClr val="1E2B3C"/>
-                          </a:solidFill>
-                        </a:rPr>
-                        <a:t>$3,202,000</a:t>
-                      </a:r>
-                    </a:p>
-                  </a:txBody>
-                  <a:tcPr>
-                    <a:solidFill>
-                      <a:srgbClr val="FFFFFF"/>
-                    </a:solidFill>
-                  </a:tcPr>
-                </a:tc>
-                <a:tc>
-                  <a:txBody>
-                    <a:bodyPr/>
-                    <a:lstStyle/>
-                    <a:p>
-                      <a:pPr algn="r"/>
-                      <a:r>
-                        <a:rPr sz="1400" b="0">
-                          <a:solidFill>
-                            <a:srgbClr val="1E2B3C"/>
-                          </a:solidFill>
-                        </a:rPr>
-                        <a:t>2.31%</a:t>
+                        <a:t>$10,563,000</a:t>
                       </a:r>
                     </a:p>
                   </a:txBody>
@@ -3820,146 +4096,14 @@
                   </a:tcPr>
                 </a:tc>
               </a:tr>
-              <a:tr h="504000">
+              <a:tr h="468000">
                 <a:tc>
                   <a:txBody>
                     <a:bodyPr/>
                     <a:lstStyle/>
                     <a:p>
                       <a:r>
-                        <a:rPr sz="1400" b="0">
-                          <a:solidFill>
-                            <a:srgbClr val="1E2B3C"/>
-                          </a:solidFill>
-                        </a:rPr>
-                        <a:t>Stage 1</a:t>
-                      </a:r>
-                    </a:p>
-                  </a:txBody>
-                  <a:tcPr>
-                    <a:solidFill>
-                      <a:srgbClr val="F3F5F7"/>
-                    </a:solidFill>
-                  </a:tcPr>
-                </a:tc>
-                <a:tc>
-                  <a:txBody>
-                    <a:bodyPr/>
-                    <a:lstStyle/>
-                    <a:p>
-                      <a:r>
-                        <a:rPr sz="1400" b="0">
-                          <a:solidFill>
-                            <a:srgbClr val="1E2B3C"/>
-                          </a:solidFill>
-                        </a:rPr>
-                        <a:t>PL60</a:t>
-                      </a:r>
-                    </a:p>
-                  </a:txBody>
-                  <a:tcPr>
-                    <a:solidFill>
-                      <a:srgbClr val="F3F5F7"/>
-                    </a:solidFill>
-                  </a:tcPr>
-                </a:tc>
-                <a:tc>
-                  <a:txBody>
-                    <a:bodyPr/>
-                    <a:lstStyle/>
-                    <a:p>
-                      <a:pPr algn="r"/>
-                      <a:r>
-                        <a:rPr sz="1400" b="0">
-                          <a:solidFill>
-                            <a:srgbClr val="1E2B3C"/>
-                          </a:solidFill>
-                        </a:rPr>
-                        <a:t>20,180</a:t>
-                      </a:r>
-                    </a:p>
-                  </a:txBody>
-                  <a:tcPr>
-                    <a:solidFill>
-                      <a:srgbClr val="F3F5F7"/>
-                    </a:solidFill>
-                  </a:tcPr>
-                </a:tc>
-                <a:tc>
-                  <a:txBody>
-                    <a:bodyPr/>
-                    <a:lstStyle/>
-                    <a:p>
-                      <a:pPr algn="r"/>
-                      <a:r>
-                        <a:rPr sz="1400" b="0">
-                          <a:solidFill>
-                            <a:srgbClr val="1E2B3C"/>
-                          </a:solidFill>
-                        </a:rPr>
-                        <a:t>$330,436,000</a:t>
-                      </a:r>
-                    </a:p>
-                  </a:txBody>
-                  <a:tcPr>
-                    <a:solidFill>
-                      <a:srgbClr val="F3F5F7"/>
-                    </a:solidFill>
-                  </a:tcPr>
-                </a:tc>
-                <a:tc>
-                  <a:txBody>
-                    <a:bodyPr/>
-                    <a:lstStyle/>
-                    <a:p>
-                      <a:pPr algn="r"/>
-                      <a:r>
-                        <a:rPr sz="1400" b="0">
-                          <a:solidFill>
-                            <a:srgbClr val="1E2B3C"/>
-                          </a:solidFill>
-                        </a:rPr>
-                        <a:t>$7,731,000</a:t>
-                      </a:r>
-                    </a:p>
-                  </a:txBody>
-                  <a:tcPr>
-                    <a:solidFill>
-                      <a:srgbClr val="F3F5F7"/>
-                    </a:solidFill>
-                  </a:tcPr>
-                </a:tc>
-                <a:tc>
-                  <a:txBody>
-                    <a:bodyPr/>
-                    <a:lstStyle/>
-                    <a:p>
-                      <a:pPr algn="r"/>
-                      <a:r>
-                        <a:rPr sz="1400" b="0">
-                          <a:solidFill>
-                            <a:srgbClr val="1E2B3C"/>
-                          </a:solidFill>
-                        </a:rPr>
-                        <a:t>2.34%</a:t>
-                      </a:r>
-                    </a:p>
-                  </a:txBody>
-                  <a:tcPr>
-                    <a:solidFill>
-                      <a:srgbClr val="F3F5F7"/>
-                    </a:solidFill>
-                  </a:tcPr>
-                </a:tc>
-              </a:tr>
-              <a:tr h="504000">
-                <a:tc>
-                  <a:txBody>
-                    <a:bodyPr/>
-                    <a:lstStyle/>
-                    <a:p>
-                      <a:r>
-                        <a:rPr sz="1400" b="0">
+                        <a:rPr sz="1600" b="0">
                           <a:solidFill>
                             <a:srgbClr val="1E2B3C"/>
                           </a:solidFill>
@@ -3979,13 +4123,14 @@
                     <a:bodyPr/>
                     <a:lstStyle/>
                     <a:p>
+                      <a:pPr algn="r"/>
                       <a:r>
-                        <a:rPr sz="1400" b="0">
+                        <a:rPr sz="1600" b="0">
                           <a:solidFill>
                             <a:srgbClr val="1E2B3C"/>
                           </a:solidFill>
                         </a:rPr>
-                        <a:t>PL36</a:t>
+                        <a:t>3,266</a:t>
                       </a:r>
                     </a:p>
                   </a:txBody>
@@ -4002,18 +4147,41 @@
                     <a:p>
                       <a:pPr algn="r"/>
                       <a:r>
-                        <a:rPr sz="1400" b="0">
+                        <a:rPr sz="1600" b="0">
                           <a:solidFill>
                             <a:srgbClr val="1E2B3C"/>
                           </a:solidFill>
                         </a:rPr>
-                        <a:t>1,421</a:t>
+                        <a:t>$2,597,000</a:t>
                       </a:r>
                     </a:p>
                   </a:txBody>
                   <a:tcPr>
                     <a:solidFill>
                       <a:srgbClr val="FFFFFF"/>
+                    </a:solidFill>
+                  </a:tcPr>
+                </a:tc>
+              </a:tr>
+              <a:tr h="468000">
+                <a:tc>
+                  <a:txBody>
+                    <a:bodyPr/>
+                    <a:lstStyle/>
+                    <a:p>
+                      <a:r>
+                        <a:rPr sz="1600" b="1">
+                          <a:solidFill>
+                            <a:srgbClr val="1E2B3C"/>
+                          </a:solidFill>
+                        </a:rPr>
+                        <a:t>Collective allowance</a:t>
+                      </a:r>
+                    </a:p>
+                  </a:txBody>
+                  <a:tcPr>
+                    <a:solidFill>
+                      <a:srgbClr val="EEF1F4"/>
                     </a:solidFill>
                   </a:tcPr>
                 </a:tc>
@@ -4024,18 +4192,18 @@
                     <a:p>
                       <a:pPr algn="r"/>
                       <a:r>
-                        <a:rPr sz="1400" b="0">
+                        <a:rPr sz="1600" b="1">
                           <a:solidFill>
                             <a:srgbClr val="1E2B3C"/>
                           </a:solidFill>
                         </a:rPr>
-                        <a:t>$11,728,000</a:t>
+                        <a:t>40,554</a:t>
                       </a:r>
                     </a:p>
                   </a:txBody>
                   <a:tcPr>
                     <a:solidFill>
-                      <a:srgbClr val="FFFFFF"/>
+                      <a:srgbClr val="EEF1F4"/>
                     </a:solidFill>
                   </a:tcPr>
                 </a:tc>
@@ -4046,172 +4214,18 @@
                     <a:p>
                       <a:pPr algn="r"/>
                       <a:r>
-                        <a:rPr sz="1400" b="0">
+                        <a:rPr sz="1600" b="1">
                           <a:solidFill>
                             <a:srgbClr val="1E2B3C"/>
                           </a:solidFill>
                         </a:rPr>
-                        <a:t>$681,000</a:t>
+                        <a:t>$13,160,000</a:t>
                       </a:r>
                     </a:p>
                   </a:txBody>
                   <a:tcPr>
                     <a:solidFill>
-                      <a:srgbClr val="FFFFFF"/>
-                    </a:solidFill>
-                  </a:tcPr>
-                </a:tc>
-                <a:tc>
-                  <a:txBody>
-                    <a:bodyPr/>
-                    <a:lstStyle/>
-                    <a:p>
-                      <a:pPr algn="r"/>
-                      <a:r>
-                        <a:rPr sz="1400" b="0">
-                          <a:solidFill>
-                            <a:srgbClr val="1E2B3C"/>
-                          </a:solidFill>
-                        </a:rPr>
-                        <a:t>5.81%</a:t>
-                      </a:r>
-                    </a:p>
-                  </a:txBody>
-                  <a:tcPr>
-                    <a:solidFill>
-                      <a:srgbClr val="FFFFFF"/>
-                    </a:solidFill>
-                  </a:tcPr>
-                </a:tc>
-              </a:tr>
-              <a:tr h="504000">
-                <a:tc>
-                  <a:txBody>
-                    <a:bodyPr/>
-                    <a:lstStyle/>
-                    <a:p>
-                      <a:r>
-                        <a:rPr sz="1400" b="0">
-                          <a:solidFill>
-                            <a:srgbClr val="1E2B3C"/>
-                          </a:solidFill>
-                        </a:rPr>
-                        <a:t>Stage 2</a:t>
-                      </a:r>
-                    </a:p>
-                  </a:txBody>
-                  <a:tcPr>
-                    <a:solidFill>
-                      <a:srgbClr val="F3F5F7"/>
-                    </a:solidFill>
-                  </a:tcPr>
-                </a:tc>
-                <a:tc>
-                  <a:txBody>
-                    <a:bodyPr/>
-                    <a:lstStyle/>
-                    <a:p>
-                      <a:r>
-                        <a:rPr sz="1400" b="0">
-                          <a:solidFill>
-                            <a:srgbClr val="1E2B3C"/>
-                          </a:solidFill>
-                        </a:rPr>
-                        <a:t>PL60</a:t>
-                      </a:r>
-                    </a:p>
-                  </a:txBody>
-                  <a:tcPr>
-                    <a:solidFill>
-                      <a:srgbClr val="F3F5F7"/>
-                    </a:solidFill>
-                  </a:tcPr>
-                </a:tc>
-                <a:tc>
-                  <a:txBody>
-                    <a:bodyPr/>
-                    <a:lstStyle/>
-                    <a:p>
-                      <a:pPr algn="r"/>
-                      <a:r>
-                        <a:rPr sz="1400" b="0">
-                          <a:solidFill>
-                            <a:srgbClr val="1E2B3C"/>
-                          </a:solidFill>
-                        </a:rPr>
-                        <a:t>1,844</a:t>
-                      </a:r>
-                    </a:p>
-                  </a:txBody>
-                  <a:tcPr>
-                    <a:solidFill>
-                      <a:srgbClr val="F3F5F7"/>
-                    </a:solidFill>
-                  </a:tcPr>
-                </a:tc>
-                <a:tc>
-                  <a:txBody>
-                    <a:bodyPr/>
-                    <a:lstStyle/>
-                    <a:p>
-                      <a:pPr algn="r"/>
-                      <a:r>
-                        <a:rPr sz="1400" b="0">
-                          <a:solidFill>
-                            <a:srgbClr val="1E2B3C"/>
-                          </a:solidFill>
-                        </a:rPr>
-                        <a:t>$28,735,000</a:t>
-                      </a:r>
-                    </a:p>
-                  </a:txBody>
-                  <a:tcPr>
-                    <a:solidFill>
-                      <a:srgbClr val="F3F5F7"/>
-                    </a:solidFill>
-                  </a:tcPr>
-                </a:tc>
-                <a:tc>
-                  <a:txBody>
-                    <a:bodyPr/>
-                    <a:lstStyle/>
-                    <a:p>
-                      <a:pPr algn="r"/>
-                      <a:r>
-                        <a:rPr sz="1400" b="0">
-                          <a:solidFill>
-                            <a:srgbClr val="1E2B3C"/>
-                          </a:solidFill>
-                        </a:rPr>
-                        <a:t>$2,159,000</a:t>
-                      </a:r>
-                    </a:p>
-                  </a:txBody>
-                  <a:tcPr>
-                    <a:solidFill>
-                      <a:srgbClr val="F3F5F7"/>
-                    </a:solidFill>
-                  </a:tcPr>
-                </a:tc>
-                <a:tc>
-                  <a:txBody>
-                    <a:bodyPr/>
-                    <a:lstStyle/>
-                    <a:p>
-                      <a:pPr algn="r"/>
-                      <a:r>
-                        <a:rPr sz="1400" b="0">
-                          <a:solidFill>
-                            <a:srgbClr val="1E2B3C"/>
-                          </a:solidFill>
-                        </a:rPr>
-                        <a:t>7.51%</a:t>
-                      </a:r>
-                    </a:p>
-                  </a:txBody>
-                  <a:tcPr>
-                    <a:solidFill>
-                      <a:srgbClr val="F3F5F7"/>
+                      <a:srgbClr val="EEF1F4"/>
                     </a:solidFill>
                   </a:tcPr>
                 </a:tc>
@@ -4228,8 +4242,8 @@
         </p:nvSpPr>
         <p:spPr>
           <a:xfrm>
-            <a:off x="576000" y="4680000"/>
-            <a:ext cx="10980000" cy="1260000"/>
+            <a:off x="576000" y="4176000"/>
+            <a:ext cx="10980000" cy="1440000"/>
           </a:xfrm>
           <a:prstGeom prst="rect">
             <a:avLst/>
@@ -4243,12 +4257,12 @@
           <a:lstStyle/>
           <a:p>
             <a:r>
-              <a:rPr sz="1100">
+              <a:rPr sz="1200">
                 <a:solidFill>
                   <a:srgbClr val="5B6670"/>
                 </a:solidFill>
               </a:rPr>
-              <a:t>Probability of default is read from the PLPD-2026.06 curve from each loan's months on book at the reporting date, conditional on the loan still performing, with the 2.4 stage 2 scalar; scenarios weighted 55 / 30 / 15 per cent (multiplier 1.0600). Amounts to the nearest thousand dollars.</a:t>
+              <a:t>Each performing loan's monthly default probability comes from the PLPD-2026.06 curve from its months on book, conditioned on the share of the development loans still open and not in default at that point; stage 2 carries the 2.4 scalar and the scenarios are weighted 55 / 30 / 15 per cent (multiplier 1.06). Amounts to the nearest thousand dollars.</a:t>
             </a:r>
           </a:p>
         </p:txBody>
@@ -4256,6 +4270,39 @@
       <p:sp>
         <p:nvSpPr>
           <p:cNvPr id="5" name="TextBox 4"/>
+          <p:cNvSpPr txBox="1"/>
+          <p:nvPr/>
+        </p:nvSpPr>
+        <p:spPr>
+          <a:xfrm>
+            <a:off x="576000" y="6048000"/>
+            <a:ext cx="10980000" cy="288000"/>
+          </a:xfrm>
+          <a:prstGeom prst="rect">
+            <a:avLst/>
+          </a:prstGeom>
+          <a:noFill/>
+        </p:spPr>
+        <p:txBody>
+          <a:bodyPr wrap="none">
+            <a:spAutoFit/>
+          </a:bodyPr>
+          <a:lstStyle/>
+          <a:p>
+            <a:r>
+              <a:rPr sz="900">
+                <a:solidFill>
+                  <a:srgbClr val="5B6670"/>
+                </a:solidFill>
+              </a:rPr>
+              <a:t>Source: loan system extract at 30 September 2026; PLPD-2026.06 curve; scenarios approved 18 September 2026</a:t>
+            </a:r>
+          </a:p>
+        </p:txBody>
+      </p:sp>
+      <p:sp>
+        <p:nvSpPr>
+          <p:cNvPr id="6" name="TextBox 5"/>
           <p:cNvSpPr txBox="1"/>
           <p:nvPr/>
         </p:nvSpPr>
@@ -4332,7 +4379,7 @@
                   <a:srgbClr val="1E2B3C"/>
                 </a:solidFill>
               </a:rPr>
-              <a:t>2026 PL60 lending carries the largest share of the allowance, $5,763,000</a:t>
+              <a:t>1,599 stage 1 loans moved to stage 2 or 3 this quarter and 1,028 stage 2 loans returned to stage 1</a:t>
             </a:r>
           </a:p>
           <a:p>
@@ -4342,7 +4389,7 @@
                   <a:srgbClr val="5B6670"/>
                 </a:solidFill>
               </a:rPr>
-              <a:t>Collective ECL allowance by drawdown year and product, AUD, 30 September 2026</a:t>
+              <a:t>Loans in stage 1 or stage 2 at 30 June 2026, by where they stand at 30 September 2026</a:t>
             </a:r>
           </a:p>
         </p:txBody>
@@ -4356,8 +4403,8 @@
           <p:nvPr/>
         </p:nvGraphicFramePr>
         <p:xfrm>
-          <a:off x="576000" y="1655999"/>
-          <a:ext cx="10980000" cy="4500000"/>
+          <a:off x="576000" y="1584000"/>
+          <a:ext cx="10980000" cy="4428000"/>
         </p:xfrm>
         <a:graphic>
           <a:graphicData uri="http://schemas.openxmlformats.org/drawingml/2006/chart">
@@ -4368,6 +4415,39 @@
       <p:sp>
         <p:nvSpPr>
           <p:cNvPr id="4" name="TextBox 3"/>
+          <p:cNvSpPr txBox="1"/>
+          <p:nvPr/>
+        </p:nvSpPr>
+        <p:spPr>
+          <a:xfrm>
+            <a:off x="576000" y="6048000"/>
+            <a:ext cx="10980000" cy="288000"/>
+          </a:xfrm>
+          <a:prstGeom prst="rect">
+            <a:avLst/>
+          </a:prstGeom>
+          <a:noFill/>
+        </p:spPr>
+        <p:txBody>
+          <a:bodyPr wrap="none">
+            <a:spAutoFit/>
+          </a:bodyPr>
+          <a:lstStyle/>
+          <a:p>
+            <a:r>
+              <a:rPr sz="900">
+                <a:solidFill>
+                  <a:srgbClr val="5B6670"/>
+                </a:solidFill>
+              </a:rPr>
+              <a:t>Source: loan system extracts at 30 June and 30 September 2026; June month-end scoring run (1 July); hardship register at 30 September. Stages under CRM-ECL-04 section 2; closed = repaid, settled or written off.</a:t>
+            </a:r>
+          </a:p>
+        </p:txBody>
+      </p:sp>
+      <p:sp>
+        <p:nvSpPr>
+          <p:cNvPr id="5" name="TextBox 4"/>
           <p:cNvSpPr txBox="1"/>
           <p:nvPr/>
         </p:nvSpPr>

</xml_diff>